<commit_message>
added github-runner in sudo
</commit_message>
<xml_diff>
--- a/07-GitHubActions/07-GitHub-Actions.pptx
+++ b/07-GitHubActions/07-GitHub-Actions.pptx
@@ -5207,7 +5207,7 @@
         <p:spPr>
           <a:xfrm>
             <a:off x="731520" y="2057400"/>
-            <a:ext cx="3383280" cy="2194560"/>
+            <a:ext cx="3383280" cy="2354580"/>
           </a:xfrm>
           <a:prstGeom prst="rect">
             <a:avLst/>
@@ -5310,7 +5310,27 @@
                 <a:ea typeface="Consolas" pitchFamily="34" charset="-122"/>
                 <a:cs typeface="Consolas" pitchFamily="34" charset="-120"/>
               </a:rPr>
-              <a:t>runs-on: ubuntu-latest</a:t>
+              <a:t>runs-on: ubuntu-latest,</a:t>
+            </a:r>
+          </a:p>
+          <a:p>
+            <a:pPr lvl="1">
+              <a:lnSpc>
+                <a:spcPct val="130000"/>
+              </a:lnSpc>
+              <a:spcAft>
+                <a:spcPts val="400"/>
+              </a:spcAft>
+              <a:buSzPct val="100000"/>
+            </a:pPr>
+            <a:r>
+              <a:rPr lang="en-US" sz="1100" dirty="0">
+                <a:solidFill>
+                  <a:srgbClr val="334155"/>
+                </a:solidFill>
+                <a:latin typeface="Consolas" pitchFamily="34" charset="0"/>
+              </a:rPr>
+              <a:t>Other images can be retrieved from: https://github.com/actions/runner-images</a:t>
             </a:r>
             <a:endParaRPr lang="en-US" sz="1200" dirty="0"/>
           </a:p>
@@ -5473,7 +5493,7 @@
         <p:spPr>
           <a:xfrm>
             <a:off x="5029200" y="2057400"/>
-            <a:ext cx="3383280" cy="2194560"/>
+            <a:ext cx="3383280" cy="2354580"/>
           </a:xfrm>
           <a:prstGeom prst="rect">
             <a:avLst/>

</xml_diff>